<commit_message>
docs(report): apply final editorial and presentation QA corrections
</commit_message>
<xml_diff>
--- a/docs/presentation/EIMS_COOP_PRESENTATION_2026.pptx
+++ b/docs/presentation/EIMS_COOP_PRESENTATION_2026.pptx
@@ -516,7 +516,7 @@
           <a:lstStyle/>
           <a:p>
             <a:r>
-              <a:t>Good morning respected members of the committee, advisor, and mentors. My name is Ratthabhumi Peansukmanee, student ID 66011198 from the International Computer Engineering Program at KMITL. Today, I am proud to present my cooperative education capstone project conducted at Kanematsu Electronics (Thailand), entitled 'Development of an Enterprise Infrastructure Management System (EIMS)'.</a:t>
+              <a:t>Good morning respected members of the committee, advisor, and mentors. My name is Ratthabhumi Peansukmanee, student ID 66011198 from the International Computer Engineering Program at KMITL. Today, I am presenting my cooperative education capstone project conducted at Kanematsu Electronics (Thailand), entitled 'Development of an Enterprise Infrastructure Management System (EIMS)'.</a:t>
             </a:r>
           </a:p>
         </p:txBody>
@@ -586,7 +586,7 @@
           <a:lstStyle/>
           <a:p>
             <a:r>
-              <a:t>We validated EIMS across five distinct layers. We did not rely on mocks alone. We tested against real PostgreSQL instances, verified TypeScript production builds, executed on physical Windows Server hardware, audited REST API responses, and conducted formal browser runtime verification under Gate A9.</a:t>
+              <a:t>We validated EIMS across distinct layers. Layer 1 executes 37 hermetic unit and ingestion tests with mocked database and analyzer components. Layer 2 verifies frontend TypeScript builds. Layer 3 reflects physical USB execution on an authorized Windows Server host. Layer 4 verifies asset-scoped REST API responses, and Layer 5 conducts browser runtime verification under Gate A9.</a:t>
             </a:r>
           </a:p>
         </p:txBody>
@@ -656,7 +656,7 @@
           <a:lstStyle/>
           <a:p>
             <a:r>
-              <a:t>Here are our key measured results from Chapter 4. Sprint 13 passed with 37 tests. The field dataset Persisted 49 Windows events across the System and Application channels. The AI analyzer triaged exactly 10 prioritized events, matching our bounded workload cap. The filtered history API returned HTTP 200, and Gate A9 browser verification passed completely.</a:t>
+              <a:t>Here are our reported results from Chapter 4. Sprint 13 passed with 37 tests. The field dataset contained 49 persisted Windows events across the System and Application channels. The analyzer triaged 10 prioritized events, matching our bounded workload cap. The filtered history API returned HTTP 200, and Gate A9 browser verification confirmed proper UI display.</a:t>
             </a:r>
           </a:p>
         </p:txBody>
@@ -726,7 +726,7 @@
           <a:lstStyle/>
           <a:p>
             <a:r>
-              <a:t>Slide 12 presents our verified end-to-end trace. I want to highlight an important academic distinction: previous field trials proved the physical USB collection and JSON generation. Our latest on-site verification verified the downstream persistence, API filtering, and frontend presentation. Separating historical collection from downstream verification demonstrates engineering integrity.</a:t>
+              <a:t>Earlier field sessions covered USB collection and JSON generation. In the latest session, I checked the stored events, analysis history, filtered API response, and dashboard. I did not repeat USB collection in that session.</a:t>
             </a:r>
           </a:p>
         </p:txBody>
@@ -796,7 +796,7 @@
           <a:lstStyle/>
           <a:p>
             <a:r>
-              <a:t>Engineering is about solving real obstacles. We encountered and resolved four key challenges: frontend hydration mismatches in Next.js, asynchronous ORM query exceptions in FastAPI, schema variations between dev mocks and real Windows event logs, and ensuring non-destructive read-only safety on production endpoints. These lessons directly enhanced the robustness of EIMS.</a:t>
+              <a:t>Engineering involves addressing practical obstacles. We encountered and resolved four key issues: Next.js hydration mismatches, an HTTP 500 error caused by a missing Optional import in the history route, distinguishing clean development databases from code defects, and isolating benchmark environments to prevent test data loss.</a:t>
             </a:r>
           </a:p>
         </p:txBody>
@@ -866,7 +866,7 @@
           <a:lstStyle/>
           <a:p>
             <a:r>
-              <a:t>Every defensible academic engineering project must have well-defined boundaries. EIMS focuses on Windows System and Application logs, uses sequential deduplication, and bounds AI triage to 10 events. It is an academic prototype baseline, not a full commercial SIEM. Our future roadmap outlines clear extensions: cross-endpoint correlation, concurrent database dedup, and multi-platform Linux/macOS support.</a:t>
+              <a:t>Every engineering project must have well-defined boundaries. EIMS focuses on Windows System and Application logs, uses sequential deduplication, and bounds AI triage to 10 events. It is an academic prototype baseline, not a full commercial SIEM. Our future roadmap outlines clear extensions: cross-endpoint correlation, concurrent database dedup, and multi-platform Linux/macOS support.</a:t>
             </a:r>
           </a:p>
         </p:txBody>
@@ -936,7 +936,7 @@
           <a:lstStyle/>
           <a:p>
             <a:r>
-              <a:t>In conclusion, EIMS successfully demonstrates the feasibility of combining centralized asset governance, portable air-gapped evidence collection, and bounded AI-assisted investigation. All 7 project objectives were achieved and empirically verified. I would like to express my sincere gratitude to Kanematsu Electronics, my workplace supervisor Mr. Chalermpol, my academic advisor Asst. Prof. Dr. Phongsak, and the evaluation committee. Thank you, and I look forward to your questions.</a:t>
+              <a:t>In conclusion, EIMS demonstrates an integrated approach to centralized asset governance, portable offline evidence collection, and bounded AI-assisted investigation. The prototype addresses the seven project objectives within its defined scope. I would like to thank Kanematsu Electronics, my workplace supervisor Mr. Chalermpol, my academic advisor Asst. Prof. Dr. Phongsak, and the committee. Thank you. I welcome your questions.</a:t>
             </a:r>
           </a:p>
         </p:txBody>
@@ -1146,7 +1146,7 @@
           <a:lstStyle/>
           <a:p>
             <a:r>
-              <a:t>Here are the 7 core objectives defined in Chapter 1. Every single objective was built, empirically tested in Chapter 4, and formally verified in Chapter 5. Notice that we focus on bounded AI assistance, sequential deduplication, and auditable evidence provenance.</a:t>
+              <a:t>Here are the seven core objectives defined in Chapter 1. The prototype addresses these seven objectives, though validation depth differs by feature. Notice that we focus on bounded AI assistance, sequential deduplication, and traceable evidence metadata.</a:t>
             </a:r>
           </a:p>
         </p:txBody>
@@ -1216,7 +1216,7 @@
           <a:lstStyle/>
           <a:p>
             <a:r>
-              <a:t>EIMS is built on modern, battle-tested open-source technologies. The collection runtime uses an embedded CPython 3.14.3 distribution on USB. The backend uses FastAPI and PostgreSQL with pgvector, decoupled through Redis and MinIO, and served via a Next.js App Router administrative interface.</a:t>
+              <a:t>EIMS is built on modern, battle-tested open-source technologies. The collection runtime uses an embedded CPython 3.14.3 distribution on USB. The backend uses FastAPI and PostgreSQL with pgvector, decoupled through Redis and MinIO, and served via a Next.js App Router interface. The embedding service initializes FastEmbed with BAAI/bge-small-en-v1.5, with SentenceTransformer all-MiniLM-L6-v2 as fallback.</a:t>
             </a:r>
           </a:p>
         </p:txBody>
@@ -1356,7 +1356,7 @@
           <a:lstStyle/>
           <a:p>
             <a:r>
-              <a:t>Figure 3.3 illustrates the offline collection lifecycle. An engineer inserts the USB drive, runs the batch launcher, and in under 60 seconds, the embedded CPython runtime captures hardware and event log telemetry into an offline JSON file. The drive is then brought to the central station where the file is submitted to the ingestion API.</a:t>
+              <a:t>Figure 3.3 illustrates the offline collection lifecycle. An engineer inserts the USB drive, runs the batch launcher, and the embedded CPython runtime captures hardware and event log telemetry into an offline JSON file. The drive is then brought to the central station where the file is submitted to the ingestion API.</a:t>
             </a:r>
           </a:p>
         </p:txBody>
@@ -1426,7 +1426,7 @@
           <a:lstStyle/>
           <a:p>
             <a:r>
-              <a:t>Deduplication is vital when engineers re-scan endpoints. We generate a SHA-256 fingerprint from the channel, provider, record ID, and kernel timestamp. An important academic distinction: EIMS implements sequential application-level deduplication. It perfectly handles sequential re-imports, but concurrent parallel imports could theoretically race because there is no composite database UNIQUE constraint.</a:t>
+              <a:t>Deduplication is vital when engineers re-scan endpoints. We generate a SHA-256 fingerprint from the asset ID, channel, provider, record ID, and recorded timestamp. An important engineering distinction: EIMS implements sequential application-level deduplication. It skips duplicates during sequential re-imports, but does not enforce database-level concurrency constraints.</a:t>
             </a:r>
           </a:p>
         </p:txBody>
@@ -1496,7 +1496,7 @@
           <a:lstStyle/>
           <a:p>
             <a:r>
-              <a:t>Our AI pipeline is strictly bounded. Rather than feeding thousands of events to an LLM, we sort by Windows severity and cap analysis at the top 10 most critical events per import. We use all-MiniLM-L6-v2 embeddings and RAG to ground the output in verified administrative solutions. Crucially, the AI is an investigation aid, not an autonomous authority.</a:t>
+              <a:t>Our analysis pipeline is bounded and conditional. Rather than feeding thousands of events to an LLM, the evaluated workflow limits analysis to at most 10 selected new events sorted by severity. The service checks curated solutions first, then uses FastEmbed or SentenceTransformer embeddings to retrieve playbook context, with optional generative expansion. Crucially, the AI provides assistive advice and does not take autonomous remediation actions.</a:t>
             </a:r>
           </a:p>
         </p:txBody>
@@ -4625,9 +4625,9 @@
           </a:p>
           <a:p>
             <a:pPr>
-              <a:defRPr sz="1250">
-                <a:solidFill>
-                  <a:srgbClr val="94A3B8"/>
+              <a:defRPr sz="1300">
+                <a:solidFill>
+                  <a:srgbClr val="E2E8F0"/>
                 </a:solidFill>
                 <a:latin typeface="Segoe UI"/>
               </a:defRPr>
@@ -4835,11 +4835,11 @@
             <a:r>
               <a:rPr sz="1100" b="0" i="0">
                 <a:solidFill>
-                  <a:srgbClr val="0F172A"/>
+                  <a:srgbClr val="000000"/>
                 </a:solidFill>
                 <a:latin typeface="Segoe UI"/>
               </a:rPr>
-              <a:t>Sprint 13 test suite executing 37 automated tests against real PostgreSQL instances validating schema parsing and deduplication.</a:t>
+              <a:t>Sprint 13 test suite (`tests/test_sprint13_evidence_ingestion.py`): 37 reported passing hermetic tests with mocked database and analyzer; separate historical/live PostgreSQL checks.</a:t>
             </a:r>
           </a:p>
         </p:txBody>
@@ -4925,7 +4925,7 @@
             <a:r>
               <a:rPr sz="1100" b="0" i="0">
                 <a:solidFill>
-                  <a:srgbClr val="0F172A"/>
+                  <a:srgbClr val="000000"/>
                 </a:solidFill>
                 <a:latin typeface="Segoe UI"/>
               </a:rPr>
@@ -5015,11 +5015,11 @@
             <a:r>
               <a:rPr sz="1100" b="0" i="0">
                 <a:solidFill>
-                  <a:srgbClr val="0F172A"/>
+                  <a:srgbClr val="000000"/>
                 </a:solidFill>
                 <a:latin typeface="Segoe UI"/>
               </a:rPr>
-              <a:t>Executed portable package on target Windows Server hardware verifying read-only WMI/CIM and event log extraction.</a:t>
+              <a:t>Executed portable package on an authorized Windows Server host verifying read-only WMI/CIM and event log extraction.</a:t>
             </a:r>
           </a:p>
         </p:txBody>
@@ -5105,7 +5105,7 @@
             <a:r>
               <a:rPr sz="1100" b="0" i="0">
                 <a:solidFill>
-                  <a:srgbClr val="0F172A"/>
+                  <a:srgbClr val="000000"/>
                 </a:solidFill>
                 <a:latin typeface="Segoe UI"/>
               </a:rPr>
@@ -5195,7 +5195,7 @@
             <a:r>
               <a:rPr sz="1100" b="0" i="0">
                 <a:solidFill>
-                  <a:srgbClr val="0F172A"/>
+                  <a:srgbClr val="000000"/>
                 </a:solidFill>
                 <a:latin typeface="Segoe UI"/>
               </a:rPr>
@@ -5266,7 +5266,7 @@
               </a:defRPr>
             </a:pPr>
             <a:r>
-              <a:t>Empirical Results &amp; Measured Field Metrics</a:t>
+              <a:t>Empirical Results &amp; Reported Field Metrics</a:t>
             </a:r>
           </a:p>
         </p:txBody>
@@ -5405,7 +5405,7 @@
               </a:spcAft>
               <a:defRPr sz="1150" b="1">
                 <a:solidFill>
-                  <a:srgbClr val="0F172A"/>
+                  <a:srgbClr val="1E3A8A"/>
                 </a:solidFill>
                 <a:latin typeface="Segoe UI"/>
               </a:defRPr>
@@ -5418,7 +5418,7 @@
             <a:pPr algn="ctr">
               <a:defRPr sz="950">
                 <a:solidFill>
-                  <a:srgbClr val="64748B"/>
+                  <a:srgbClr val="475569"/>
                 </a:solidFill>
                 <a:latin typeface="Segoe UI"/>
               </a:defRPr>
@@ -5518,7 +5518,7 @@
               </a:spcAft>
               <a:defRPr sz="1150" b="1">
                 <a:solidFill>
-                  <a:srgbClr val="0F172A"/>
+                  <a:srgbClr val="1E3A8A"/>
                 </a:solidFill>
                 <a:latin typeface="Segoe UI"/>
               </a:defRPr>
@@ -5531,7 +5531,7 @@
             <a:pPr algn="ctr">
               <a:defRPr sz="950">
                 <a:solidFill>
-                  <a:srgbClr val="64748B"/>
+                  <a:srgbClr val="475569"/>
                 </a:solidFill>
                 <a:latin typeface="Segoe UI"/>
               </a:defRPr>
@@ -5631,7 +5631,7 @@
               </a:spcAft>
               <a:defRPr sz="1150" b="1">
                 <a:solidFill>
-                  <a:srgbClr val="0F172A"/>
+                  <a:srgbClr val="1E3A8A"/>
                 </a:solidFill>
                 <a:latin typeface="Segoe UI"/>
               </a:defRPr>
@@ -5644,7 +5644,7 @@
             <a:pPr algn="ctr">
               <a:defRPr sz="950">
                 <a:solidFill>
-                  <a:srgbClr val="64748B"/>
+                  <a:srgbClr val="475569"/>
                 </a:solidFill>
                 <a:latin typeface="Segoe UI"/>
               </a:defRPr>
@@ -5744,7 +5744,7 @@
               </a:spcAft>
               <a:defRPr sz="1150" b="1">
                 <a:solidFill>
-                  <a:srgbClr val="0F172A"/>
+                  <a:srgbClr val="1E3A8A"/>
                 </a:solidFill>
                 <a:latin typeface="Segoe UI"/>
               </a:defRPr>
@@ -5757,13 +5757,13 @@
             <a:pPr algn="ctr">
               <a:defRPr sz="950">
                 <a:solidFill>
-                  <a:srgbClr val="64748B"/>
-                </a:solidFill>
-                <a:latin typeface="Segoe UI"/>
-              </a:defRPr>
-            </a:pPr>
-            <a:r>
-              <a:t>Bounded AI Cap (10/10 Analyzed)</a:t>
+                  <a:srgbClr val="475569"/>
+                </a:solidFill>
+                <a:latin typeface="Segoe UI"/>
+              </a:defRPr>
+            </a:pPr>
+            <a:r>
+              <a:t>Bounded Workload Path (10 Analyzed)</a:t>
             </a:r>
           </a:p>
         </p:txBody>
@@ -5888,11 +5888,11 @@
             <a:r>
               <a:rPr sz="1150" b="0" i="0">
                 <a:solidFill>
-                  <a:srgbClr val="0F172A"/>
+                  <a:srgbClr val="000000"/>
                 </a:solidFill>
                 <a:latin typeface="Segoe UI"/>
               </a:rPr>
-              <a:t>Synthetic test identifier `ASSET-01` representing enterprise Windows Server environment.</a:t>
+              <a:t>Anonymized host alias: `ASSET-01` representing enterprise Windows Server environment.</a:t>
             </a:r>
           </a:p>
           <a:p>
@@ -5913,7 +5913,7 @@
             <a:r>
               <a:rPr sz="1150" b="0" i="0">
                 <a:solidFill>
-                  <a:srgbClr val="0F172A"/>
+                  <a:srgbClr val="000000"/>
                 </a:solidFill>
                 <a:latin typeface="Segoe UI"/>
               </a:rPr>
@@ -5938,7 +5938,7 @@
             <a:r>
               <a:rPr sz="1150" b="0" i="0">
                 <a:solidFill>
-                  <a:srgbClr val="0F172A"/>
+                  <a:srgbClr val="000000"/>
                 </a:solidFill>
                 <a:latin typeface="Segoe UI"/>
               </a:rPr>
@@ -5963,7 +5963,7 @@
             <a:r>
               <a:rPr sz="1150" b="0" i="0">
                 <a:solidFill>
-                  <a:srgbClr val="0F172A"/>
+                  <a:srgbClr val="000000"/>
                 </a:solidFill>
                 <a:latin typeface="Segoe UI"/>
               </a:rPr>
@@ -5988,7 +5988,7 @@
             <a:r>
               <a:rPr sz="1150" b="0" i="0">
                 <a:solidFill>
-                  <a:srgbClr val="0F172A"/>
+                  <a:srgbClr val="000000"/>
                 </a:solidFill>
                 <a:latin typeface="Segoe UI"/>
               </a:rPr>
@@ -6059,7 +6059,7 @@
               </a:defRPr>
             </a:pPr>
             <a:r>
-              <a:t>Downstream Live End-to-End Verification Trace</a:t>
+              <a:t>Downstream Live Validation Workflow Trace</a:t>
             </a:r>
           </a:p>
         </p:txBody>
@@ -6799,7 +6799,7 @@
               </a:spcAft>
               <a:defRPr sz="1100">
                 <a:solidFill>
-                  <a:srgbClr val="0F172A"/>
+                  <a:srgbClr val="000000"/>
                 </a:solidFill>
                 <a:latin typeface="Segoe UI"/>
               </a:defRPr>
@@ -6832,13 +6832,13 @@
               </a:spcAft>
               <a:defRPr sz="1100">
                 <a:solidFill>
-                  <a:srgbClr val="0F172A"/>
-                </a:solidFill>
-                <a:latin typeface="Segoe UI"/>
-              </a:defRPr>
-            </a:pPr>
-            <a:r>
-              <a:t>Physical USB acquisition, elevated script execution, and raw JSON extraction were rigorously proven in earlier field trials and were intentionally NOT re-run during the final downstream gate.</a:t>
+                  <a:srgbClr val="000000"/>
+                </a:solidFill>
+                <a:latin typeface="Segoe UI"/>
+              </a:defRPr>
+            </a:pPr>
+            <a:r>
+              <a:t>Physical USB acquisition, elevated script execution, and raw JSON extraction were proven in earlier field trials and were intentionally NOT re-run during the final downstream gate.</a:t>
             </a:r>
           </a:p>
           <a:p>
@@ -6854,7 +6854,7 @@
               </a:defRPr>
             </a:pPr>
             <a:r>
-              <a:t>•  Auditability &amp; Defense:</a:t>
+              <a:t>•  Traceability &amp; Auditability:</a:t>
             </a:r>
             <a:br/>
           </a:p>
@@ -6865,7 +6865,7 @@
               </a:spcAft>
               <a:defRPr sz="1100">
                 <a:solidFill>
-                  <a:srgbClr val="0F172A"/>
+                  <a:srgbClr val="000000"/>
                 </a:solidFill>
                 <a:latin typeface="Segoe UI"/>
               </a:defRPr>
@@ -7108,7 +7108,7 @@
             <a:r>
               <a:rPr sz="1050" b="0" i="0">
                 <a:solidFill>
-                  <a:srgbClr val="0F172A"/>
+                  <a:srgbClr val="000000"/>
                 </a:solidFill>
                 <a:latin typeface="Segoe UI"/>
               </a:rPr>
@@ -7133,7 +7133,7 @@
             <a:r>
               <a:rPr sz="1050" b="0" i="0">
                 <a:solidFill>
-                  <a:srgbClr val="0F172A"/>
+                  <a:srgbClr val="000000"/>
                 </a:solidFill>
                 <a:latin typeface="Segoe UI"/>
               </a:rPr>
@@ -7158,7 +7158,7 @@
             <a:r>
               <a:rPr sz="1050" b="0" i="0">
                 <a:solidFill>
-                  <a:srgbClr val="0F172A"/>
+                  <a:srgbClr val="000000"/>
                 </a:solidFill>
                 <a:latin typeface="Segoe UI"/>
               </a:rPr>
@@ -7287,11 +7287,11 @@
             <a:r>
               <a:rPr sz="1050" b="0" i="0">
                 <a:solidFill>
-                  <a:srgbClr val="0F172A"/>
+                  <a:srgbClr val="000000"/>
                 </a:solidFill>
                 <a:latin typeface="Segoe UI"/>
               </a:rPr>
-              <a:t>Querying `/api/v1/history?asset_id=...` crashed when ORM attempted synchronous relationship loading.</a:t>
+              <a:t>Querying `/api/v1/history?asset_id=...` failed with HTTP 500 due to a missing `Optional` type import in the route handler.</a:t>
             </a:r>
           </a:p>
           <a:p>
@@ -7312,11 +7312,11 @@
             <a:r>
               <a:rPr sz="1050" b="0" i="0">
                 <a:solidFill>
-                  <a:srgbClr val="0F172A"/>
+                  <a:srgbClr val="000000"/>
                 </a:solidFill>
                 <a:latin typeface="Segoe UI"/>
               </a:rPr>
-              <a:t>Corrected asynchronous SQLAlchemy joins and applied explicit foreign-key filtering.</a:t>
+              <a:t>Added `from typing import Optional` to the route declaration (commit `acb855f`).</a:t>
             </a:r>
           </a:p>
           <a:p>
@@ -7337,11 +7337,11 @@
             <a:r>
               <a:rPr sz="1050" b="0" i="0">
                 <a:solidFill>
-                  <a:srgbClr val="0F172A"/>
+                  <a:srgbClr val="000000"/>
                 </a:solidFill>
                 <a:latin typeface="Segoe UI"/>
               </a:rPr>
-              <a:t>Asynchronous database drivers require explicit eager-loading strategies to avoid event loop blocking.</a:t>
+              <a:t>Static type annotations and import hygiene must be verified through automated linting and contract checks.</a:t>
             </a:r>
           </a:p>
         </p:txBody>
@@ -7422,7 +7422,7 @@
               </a:defRPr>
             </a:pPr>
             <a:r>
-              <a:t>Environment-Specific Dataset Variance</a:t>
+              <a:t>Developer Environment Dataset Variance</a:t>
             </a:r>
           </a:p>
         </p:txBody>
@@ -7466,11 +7466,11 @@
             <a:r>
               <a:rPr sz="1050" b="0" i="0">
                 <a:solidFill>
-                  <a:srgbClr val="0F172A"/>
+                  <a:srgbClr val="000000"/>
                 </a:solidFill>
                 <a:latin typeface="Segoe UI"/>
               </a:rPr>
-              <a:t>Local development mocks diverged from actual Windows Server event schema formats.</a:t>
+              <a:t>Local developer database was empty and did not contain the field dataset, initially appearing as an application defect.</a:t>
             </a:r>
           </a:p>
           <a:p>
@@ -7491,11 +7491,11 @@
             <a:r>
               <a:rPr sz="1050" b="0" i="0">
                 <a:solidFill>
-                  <a:srgbClr val="0F172A"/>
+                  <a:srgbClr val="000000"/>
                 </a:solidFill>
                 <a:latin typeface="Segoe UI"/>
               </a:rPr>
-              <a:t>Standardized on schema-validated Pydantic contract tests against real `.evtx` samples.</a:t>
+              <a:t>Verified environment state and populated local test records to mirror the field dataset structure.</a:t>
             </a:r>
           </a:p>
           <a:p>
@@ -7516,11 +7516,11 @@
             <a:r>
               <a:rPr sz="1050" b="0" i="0">
                 <a:solidFill>
-                  <a:srgbClr val="0F172A"/>
+                  <a:srgbClr val="000000"/>
                 </a:solidFill>
                 <a:latin typeface="Segoe UI"/>
               </a:rPr>
-              <a:t>Ingestion pipelines must validate data contracts at the gateway boundary rather than in persistence logic.</a:t>
+              <a:t>Check environment configuration and test data availability before treating empty query results as code bugs.</a:t>
             </a:r>
           </a:p>
         </p:txBody>
@@ -7601,7 +7601,7 @@
               </a:defRPr>
             </a:pPr>
             <a:r>
-              <a:t>Benchmark Data-Loss Prevention</a:t>
+              <a:t>Benchmark Database Isolation</a:t>
             </a:r>
           </a:p>
         </p:txBody>
@@ -7645,11 +7645,11 @@
             <a:r>
               <a:rPr sz="1050" b="0" i="0">
                 <a:solidFill>
-                  <a:srgbClr val="0F172A"/>
+                  <a:srgbClr val="000000"/>
                 </a:solidFill>
                 <a:latin typeface="Segoe UI"/>
               </a:rPr>
-              <a:t>Risk of destructive operations on production servers during automated evaluation.</a:t>
+              <a:t>Destructive load benchmarking against a shared local development database resulted in accidental test data loss.</a:t>
             </a:r>
           </a:p>
           <a:p>
@@ -7670,11 +7670,11 @@
             <a:r>
               <a:rPr sz="1050" b="0" i="0">
                 <a:solidFill>
-                  <a:srgbClr val="0F172A"/>
+                  <a:srgbClr val="000000"/>
                 </a:solidFill>
                 <a:latin typeface="Segoe UI"/>
               </a:rPr>
-              <a:t>Codified read-only collection rules, elevated UAC safety checks, and strict pre-flight assertions.</a:t>
+              <a:t>Enforced dedicated test databases and isolated runner environments for benchmarking scripts.</a:t>
             </a:r>
           </a:p>
           <a:p>
@@ -7695,11 +7695,11 @@
             <a:r>
               <a:rPr sz="1050" b="0" i="0">
                 <a:solidFill>
-                  <a:srgbClr val="0F172A"/>
+                  <a:srgbClr val="000000"/>
                 </a:solidFill>
                 <a:latin typeface="Segoe UI"/>
               </a:rPr>
-              <a:t>Enterprise monitoring tools must adhere to non-destructive principles to be accepted in production.</a:t>
+              <a:t>Benchmark and evaluation scripts must operate on isolated test instances to prevent accidental data loss.</a:t>
             </a:r>
           </a:p>
         </p:txBody>
@@ -7925,7 +7925,7 @@
               </a:spcAft>
               <a:defRPr sz="1100">
                 <a:solidFill>
-                  <a:srgbClr val="0F172A"/>
+                  <a:srgbClr val="000000"/>
                 </a:solidFill>
                 <a:latin typeface="Segoe UI"/>
               </a:defRPr>
@@ -7941,13 +7941,13 @@
               </a:spcAft>
               <a:defRPr sz="1100">
                 <a:solidFill>
-                  <a:srgbClr val="0F172A"/>
-                </a:solidFill>
-                <a:latin typeface="Segoe UI"/>
-              </a:defRPr>
-            </a:pPr>
-            <a:r>
-              <a:t>•  System &amp; Application Scope: Scoped strictly to System and Application channels; Security channel excluded from portable graduation scope.</a:t>
+                  <a:srgbClr val="000000"/>
+                </a:solidFill>
+                <a:latin typeface="Segoe UI"/>
+              </a:defRPr>
+            </a:pPr>
+            <a:r>
+              <a:t>•  System &amp; Application Scope: Scoped strictly to System and Application channels (default max 500 combined events).</a:t>
             </a:r>
           </a:p>
           <a:p>
@@ -7957,13 +7957,13 @@
               </a:spcAft>
               <a:defRPr sz="1100">
                 <a:solidFill>
-                  <a:srgbClr val="0F172A"/>
-                </a:solidFill>
-                <a:latin typeface="Segoe UI"/>
-              </a:defRPr>
-            </a:pPr>
-            <a:r>
-              <a:t>•  Sequential Dedup Only: Enforces application-level sequential protection; does not provide distributed concurrency guarantees.</a:t>
+                  <a:srgbClr val="000000"/>
+                </a:solidFill>
+                <a:latin typeface="Segoe UI"/>
+              </a:defRPr>
+            </a:pPr>
+            <a:r>
+              <a:t>•  Sequential Dedup Only: Enforces application-level sequential protection; does not provide distributed database concurrency guarantees.</a:t>
             </a:r>
           </a:p>
           <a:p>
@@ -7973,13 +7973,13 @@
               </a:spcAft>
               <a:defRPr sz="1100">
                 <a:solidFill>
-                  <a:srgbClr val="0F172A"/>
-                </a:solidFill>
-                <a:latin typeface="Segoe UI"/>
-              </a:defRPr>
-            </a:pPr>
-            <a:r>
-              <a:t>•  Bounded Triage Capacity: Evaluates at most 10 prioritized events per batch import.</a:t>
+                  <a:srgbClr val="000000"/>
+                </a:solidFill>
+                <a:latin typeface="Segoe UI"/>
+              </a:defRPr>
+            </a:pPr>
+            <a:r>
+              <a:t>•  Bounded Triage Capacity: Evaluated workflow limits analysis to at most 10 prioritized events per batch import.</a:t>
             </a:r>
           </a:p>
           <a:p>
@@ -7989,7 +7989,7 @@
               </a:spcAft>
               <a:defRPr sz="1100">
                 <a:solidFill>
-                  <a:srgbClr val="0F172A"/>
+                  <a:srgbClr val="000000"/>
                 </a:solidFill>
                 <a:latin typeface="Segoe UI"/>
               </a:defRPr>
@@ -8005,13 +8005,13 @@
               </a:spcAft>
               <a:defRPr sz="1100">
                 <a:solidFill>
-                  <a:srgbClr val="0F172A"/>
-                </a:solidFill>
-                <a:latin typeface="Segoe UI"/>
-              </a:defRPr>
-            </a:pPr>
-            <a:r>
-              <a:t>•  Academic Baseline: Prototype implementation; not a hardened commercial SIEM or certified forensic suite.</a:t>
+                  <a:srgbClr val="000000"/>
+                </a:solidFill>
+                <a:latin typeface="Segoe UI"/>
+              </a:defRPr>
+            </a:pPr>
+            <a:r>
+              <a:t>•  Academic Prototype: Prototype implementation; not a commercial SIEM or certified forensic suite.</a:t>
             </a:r>
           </a:p>
         </p:txBody>
@@ -8125,13 +8125,13 @@
               </a:spcAft>
               <a:defRPr sz="1100">
                 <a:solidFill>
-                  <a:srgbClr val="0F172A"/>
-                </a:solidFill>
-                <a:latin typeface="Segoe UI"/>
-              </a:defRPr>
-            </a:pPr>
-            <a:r>
-              <a:t>•  Cross-Endpoint Event Correlation: Implement temporal clustering to detect infrastructure-wide cascading failures.</a:t>
+                  <a:srgbClr val="000000"/>
+                </a:solidFill>
+                <a:latin typeface="Segoe UI"/>
+              </a:defRPr>
+            </a:pPr>
+            <a:r>
+              <a:t>•  Cross-Endpoint Correlation: Investigate temporal clustering to detect infrastructure-wide event sequences.</a:t>
             </a:r>
           </a:p>
           <a:p>
@@ -8141,13 +8141,13 @@
               </a:spcAft>
               <a:defRPr sz="1100">
                 <a:solidFill>
-                  <a:srgbClr val="0F172A"/>
-                </a:solidFill>
-                <a:latin typeface="Segoe UI"/>
-              </a:defRPr>
-            </a:pPr>
-            <a:r>
-              <a:t>•  Database-Level Concurrency Protection: Introduce composite database constraints to guarantee race-condition safety under parallel imports.</a:t>
+                  <a:srgbClr val="000000"/>
+                </a:solidFill>
+                <a:latin typeface="Segoe UI"/>
+              </a:defRPr>
+            </a:pPr>
+            <a:r>
+              <a:t>•  Database-Level Concurrency: Evaluate database-level constraints for concurrent ingestion safety.</a:t>
             </a:r>
           </a:p>
           <a:p>
@@ -8157,13 +8157,13 @@
               </a:spcAft>
               <a:defRPr sz="1100">
                 <a:solidFill>
-                  <a:srgbClr val="0F172A"/>
-                </a:solidFill>
-                <a:latin typeface="Segoe UI"/>
-              </a:defRPr>
-            </a:pPr>
-            <a:r>
-              <a:t>•  High-Availability Clustering: Deploy stateless backend pods and PostgreSQL replicas via Kubernetes.</a:t>
+                  <a:srgbClr val="000000"/>
+                </a:solidFill>
+                <a:latin typeface="Segoe UI"/>
+              </a:defRPr>
+            </a:pPr>
+            <a:r>
+              <a:t>•  Infrastructure Scaling: Connection pooling and containerized deployment as operational needs expand.</a:t>
             </a:r>
           </a:p>
           <a:p>
@@ -8173,13 +8173,13 @@
               </a:spcAft>
               <a:defRPr sz="1100">
                 <a:solidFill>
-                  <a:srgbClr val="0F172A"/>
-                </a:solidFill>
-                <a:latin typeface="Segoe UI"/>
-              </a:defRPr>
-            </a:pPr>
-            <a:r>
-              <a:t>•  Enterprise Identity Federation: Integrate SAML 2.0 / OpenID Connect for Active Directory Single Sign-On (SSO).</a:t>
+                  <a:srgbClr val="000000"/>
+                </a:solidFill>
+                <a:latin typeface="Segoe UI"/>
+              </a:defRPr>
+            </a:pPr>
+            <a:r>
+              <a:t>•  Directory Integration: Investigate enterprise single sign-on (SSO) integration with corporate Active Directory.</a:t>
             </a:r>
           </a:p>
           <a:p>
@@ -8189,13 +8189,13 @@
               </a:spcAft>
               <a:defRPr sz="1100">
                 <a:solidFill>
-                  <a:srgbClr val="0F172A"/>
-                </a:solidFill>
-                <a:latin typeface="Segoe UI"/>
-              </a:defRPr>
-            </a:pPr>
-            <a:r>
-              <a:t>•  Multi-Platform Collectors: Extend embedded Python auditor to Linux systemd journals and macOS Unified Logging.</a:t>
+                  <a:srgbClr val="000000"/>
+                </a:solidFill>
+                <a:latin typeface="Segoe UI"/>
+              </a:defRPr>
+            </a:pPr>
+            <a:r>
+              <a:t>•  Cross-Platform Collection: Study portable collector implementations for Linux systemd and macOS logging.</a:t>
             </a:r>
           </a:p>
         </p:txBody>
@@ -8340,7 +8340,7 @@
               </a:defRPr>
             </a:pPr>
             <a:r>
-              <a:t>2. Air-Gapped Evidence Acquisition: Proved non-destructive offline collection using embedded CPython 3.14.3 runtimes.</a:t>
+              <a:t>2. Air-Gapped Evidence Acquisition: Demonstrated non-destructive offline collection using embedded CPython 3.14.3 runtimes.</a:t>
             </a:r>
           </a:p>
           <a:p>
@@ -8356,7 +8356,7 @@
               </a:defRPr>
             </a:pPr>
             <a:r>
-              <a:t>3. Defensible Deduplication &amp; Prioritization: Implemented sequential SHA-256 event fingerprinting and deterministic triage.</a:t>
+              <a:t>3. Deterministic Deduplication &amp; Prioritization: Implemented sequential SHA-256 event fingerprinting and deterministic triage.</a:t>
             </a:r>
           </a:p>
           <a:p>
@@ -8394,15 +8394,15 @@
           <a:p>
             <a:br/>
             <a:pPr>
-              <a:defRPr sz="1800" b="1">
-                <a:solidFill>
-                  <a:srgbClr val="93C5FD"/>
-                </a:solidFill>
-                <a:latin typeface="Segoe UI"/>
-              </a:defRPr>
-            </a:pPr>
-            <a:r>
-              <a:t>Thank you for your attention. I am now pleased to welcome your questions.</a:t>
+              <a:defRPr sz="2000" b="1">
+                <a:solidFill>
+                  <a:srgbClr val="FFFFFF"/>
+                </a:solidFill>
+                <a:latin typeface="Segoe UI"/>
+              </a:defRPr>
+            </a:pPr>
+            <a:r>
+              <a:t>Thank you. I welcome your questions.</a:t>
             </a:r>
           </a:p>
         </p:txBody>
@@ -8628,7 +8628,7 @@
               </a:spcAft>
               <a:defRPr sz="1200" b="1">
                 <a:solidFill>
-                  <a:srgbClr val="0F172A"/>
+                  <a:srgbClr val="1E3A8A"/>
                 </a:solidFill>
                 <a:latin typeface="Segoe UI"/>
               </a:defRPr>
@@ -8639,7 +8639,7 @@
             <a:r>
               <a:rPr sz="1200" b="0" i="0">
                 <a:solidFill>
-                  <a:srgbClr val="64748B"/>
+                  <a:srgbClr val="000000"/>
                 </a:solidFill>
                 <a:latin typeface="Segoe UI"/>
               </a:rPr>
@@ -8653,7 +8653,7 @@
               </a:spcAft>
               <a:defRPr sz="1200" b="1">
                 <a:solidFill>
-                  <a:srgbClr val="0F172A"/>
+                  <a:srgbClr val="1E3A8A"/>
                 </a:solidFill>
                 <a:latin typeface="Segoe UI"/>
               </a:defRPr>
@@ -8664,7 +8664,7 @@
             <a:r>
               <a:rPr sz="1200" b="0" i="0">
                 <a:solidFill>
-                  <a:srgbClr val="64748B"/>
+                  <a:srgbClr val="000000"/>
                 </a:solidFill>
                 <a:latin typeface="Segoe UI"/>
               </a:rPr>
@@ -8678,7 +8678,7 @@
               </a:spcAft>
               <a:defRPr sz="1200" b="1">
                 <a:solidFill>
-                  <a:srgbClr val="0F172A"/>
+                  <a:srgbClr val="1E3A8A"/>
                 </a:solidFill>
                 <a:latin typeface="Segoe UI"/>
               </a:defRPr>
@@ -8689,7 +8689,7 @@
             <a:r>
               <a:rPr sz="1200" b="0" i="0">
                 <a:solidFill>
-                  <a:srgbClr val="64748B"/>
+                  <a:srgbClr val="000000"/>
                 </a:solidFill>
                 <a:latin typeface="Segoe UI"/>
               </a:rPr>
@@ -8703,7 +8703,7 @@
               </a:spcAft>
               <a:defRPr sz="1200" b="1">
                 <a:solidFill>
-                  <a:srgbClr val="0F172A"/>
+                  <a:srgbClr val="1E3A8A"/>
                 </a:solidFill>
                 <a:latin typeface="Segoe UI"/>
               </a:defRPr>
@@ -8714,7 +8714,7 @@
             <a:r>
               <a:rPr sz="1200" b="0" i="0">
                 <a:solidFill>
-                  <a:srgbClr val="64748B"/>
+                  <a:srgbClr val="000000"/>
                 </a:solidFill>
                 <a:latin typeface="Segoe UI"/>
               </a:rPr>
@@ -8728,7 +8728,7 @@
               </a:spcAft>
               <a:defRPr sz="1200" b="1">
                 <a:solidFill>
-                  <a:srgbClr val="0F172A"/>
+                  <a:srgbClr val="1E3A8A"/>
                 </a:solidFill>
                 <a:latin typeface="Segoe UI"/>
               </a:defRPr>
@@ -8739,7 +8739,7 @@
             <a:r>
               <a:rPr sz="1200" b="0" i="0">
                 <a:solidFill>
-                  <a:srgbClr val="64748B"/>
+                  <a:srgbClr val="000000"/>
                 </a:solidFill>
                 <a:latin typeface="Segoe UI"/>
               </a:rPr>
@@ -8874,7 +8874,7 @@
               </a:spcAft>
               <a:defRPr sz="1100">
                 <a:solidFill>
-                  <a:srgbClr val="0F172A"/>
+                  <a:srgbClr val="000000"/>
                 </a:solidFill>
                 <a:latin typeface="Segoe UI"/>
               </a:defRPr>
@@ -8915,13 +8915,13 @@
               </a:spcAft>
               <a:defRPr sz="1100">
                 <a:solidFill>
-                  <a:srgbClr val="0F172A"/>
-                </a:solidFill>
-                <a:latin typeface="Segoe UI"/>
-              </a:defRPr>
-            </a:pPr>
-            <a:r>
-              <a:t>1. Engineered an authoritative central asset registry with hardware fingerprinting.</a:t>
+                  <a:srgbClr val="000000"/>
+                </a:solidFill>
+                <a:latin typeface="Segoe UI"/>
+              </a:defRPr>
+            </a:pPr>
+            <a:r>
+              <a:t>1. Engineered central asset records anchored by cryptographic hardware composite fingerprints.</a:t>
             </a:r>
             <a:br/>
             <a:r>
@@ -9127,7 +9127,7 @@
             <a:r>
               <a:rPr sz="1100" b="0" i="0">
                 <a:solidFill>
-                  <a:srgbClr val="0F172A"/>
+                  <a:srgbClr val="000000"/>
                 </a:solidFill>
                 <a:latin typeface="Segoe UI"/>
               </a:rPr>
@@ -9217,7 +9217,7 @@
             <a:r>
               <a:rPr sz="1100" b="0" i="0">
                 <a:solidFill>
-                  <a:srgbClr val="0F172A"/>
+                  <a:srgbClr val="000000"/>
                 </a:solidFill>
                 <a:latin typeface="Segoe UI"/>
               </a:rPr>
@@ -9307,7 +9307,7 @@
             <a:r>
               <a:rPr sz="1100" b="0" i="0">
                 <a:solidFill>
-                  <a:srgbClr val="0F172A"/>
+                  <a:srgbClr val="000000"/>
                 </a:solidFill>
                 <a:latin typeface="Segoe UI"/>
               </a:rPr>
@@ -9397,7 +9397,7 @@
             <a:r>
               <a:rPr sz="1100" b="0" i="0">
                 <a:solidFill>
-                  <a:srgbClr val="0F172A"/>
+                  <a:srgbClr val="000000"/>
                 </a:solidFill>
                 <a:latin typeface="Segoe UI"/>
               </a:rPr>
@@ -9487,7 +9487,7 @@
             <a:r>
               <a:rPr sz="1100" b="0" i="0">
                 <a:solidFill>
-                  <a:srgbClr val="0F172A"/>
+                  <a:srgbClr val="000000"/>
                 </a:solidFill>
                 <a:latin typeface="Segoe UI"/>
               </a:rPr>
@@ -9558,7 +9558,7 @@
               </a:defRPr>
             </a:pPr>
             <a:r>
-              <a:t>Project Objectives (Mapped 1:1 to Implementation &amp; Evaluation)</a:t>
+              <a:t>Project Objectives (Core Engineering Scope)</a:t>
             </a:r>
           </a:p>
         </p:txBody>
@@ -9689,11 +9689,11 @@
             <a:r>
               <a:rPr sz="1100" b="0" i="0">
                 <a:solidFill>
-                  <a:srgbClr val="0F172A"/>
+                  <a:srgbClr val="000000"/>
                 </a:solidFill>
                 <a:latin typeface="Segoe UI"/>
               </a:rPr>
-              <a:t>Establish authoritative compute asset entity records anchored by cryptographic hardware composite fingerprints.</a:t>
+              <a:t>Establish central asset records anchored by cryptographic hardware composite fingerprints.</a:t>
             </a:r>
           </a:p>
         </p:txBody>
@@ -9779,11 +9779,11 @@
             <a:r>
               <a:rPr sz="1100" b="0" i="0">
                 <a:solidFill>
-                  <a:srgbClr val="0F172A"/>
+                  <a:srgbClr val="000000"/>
                 </a:solidFill>
                 <a:latin typeface="Segoe UI"/>
               </a:rPr>
-              <a:t>Implement an episodic, read-only collection tool on portable media requiring zero target host software dependencies.</a:t>
+              <a:t>Implement a portable, read-only collection utility for disconnected Windows hosts requiring no persistent agent installation.</a:t>
             </a:r>
           </a:p>
         </p:txBody>
@@ -9864,16 +9864,16 @@
               </a:defRPr>
             </a:pPr>
             <a:r>
-              <a:t>OBJ-3: Structured Offline Evidence Persistence: </a:t>
+              <a:t>OBJ-3: Ingestion &amp; Normalization Pipeline: </a:t>
             </a:r>
             <a:r>
               <a:rPr sz="1100" b="0" i="0">
                 <a:solidFill>
-                  <a:srgbClr val="0F172A"/>
+                  <a:srgbClr val="000000"/>
                 </a:solidFill>
                 <a:latin typeface="Segoe UI"/>
               </a:rPr>
-              <a:t>Extract hardware inventory and Windows Event Logs (System &amp; Application, 24h window) into schema-validated JSON.</a:t>
+              <a:t>Ingest and normalize offline evidence payloads into schema-validated relational records.</a:t>
             </a:r>
           </a:p>
         </p:txBody>
@@ -9954,12 +9954,12 @@
               </a:defRPr>
             </a:pPr>
             <a:r>
-              <a:t>OBJ-4: Deduplication &amp; Prioritization Pipeline: </a:t>
+              <a:t>OBJ-4: Sequential Deduplication: </a:t>
             </a:r>
             <a:r>
               <a:rPr sz="1100" b="0" i="0">
                 <a:solidFill>
-                  <a:srgbClr val="0F172A"/>
+                  <a:srgbClr val="000000"/>
                 </a:solidFill>
                 <a:latin typeface="Segoe UI"/>
               </a:rPr>
@@ -10044,16 +10044,16 @@
               </a:defRPr>
             </a:pPr>
             <a:r>
-              <a:t>OBJ-5: Bounded AI-assisted Investigation: </a:t>
+              <a:t>OBJ-5: Assisted AI Analysis: </a:t>
             </a:r>
             <a:r>
               <a:rPr sz="1100" b="0" i="0">
                 <a:solidFill>
-                  <a:srgbClr val="0F172A"/>
+                  <a:srgbClr val="000000"/>
                 </a:solidFill>
                 <a:latin typeface="Segoe UI"/>
               </a:rPr>
-              <a:t>Deploy semantic embeddings and RAG triage bounded to at most 10 prioritized events per batch import to assist human engineers.</a:t>
+              <a:t>Deploy semantic embeddings and retrieval-augmented generation to provide assistive diagnostic context for prioritized events (bounded at most 10 per import).</a:t>
             </a:r>
           </a:p>
         </p:txBody>
@@ -10134,16 +10134,16 @@
               </a:defRPr>
             </a:pPr>
             <a:r>
-              <a:t>OBJ-6: Historical Provenance &amp; Auditability: </a:t>
+              <a:t>OBJ-6: Centralized Investigation Dashboard: </a:t>
             </a:r>
             <a:r>
               <a:rPr sz="1100" b="0" i="0">
                 <a:solidFill>
-                  <a:srgbClr val="0F172A"/>
+                  <a:srgbClr val="000000"/>
                 </a:solidFill>
                 <a:latin typeface="Segoe UI"/>
               </a:rPr>
-              <a:t>Maintain persistent AnalysisHistory records linking diagnostic findings, timestamps, and model provenance to the asset.</a:t>
+              <a:t>Deliver a responsive web interface displaying endpoint profiles, compliance status, event logs, and assisted findings.</a:t>
             </a:r>
           </a:p>
         </p:txBody>
@@ -10224,16 +10224,16 @@
               </a:defRPr>
             </a:pPr>
             <a:r>
-              <a:t>OBJ-7: Centralized Investigation Dashboard: </a:t>
+              <a:t>OBJ-7: Empirical System Validation: </a:t>
             </a:r>
             <a:r>
               <a:rPr sz="1100" b="0" i="0">
                 <a:solidFill>
-                  <a:srgbClr val="0F172A"/>
+                  <a:srgbClr val="000000"/>
                 </a:solidFill>
                 <a:latin typeface="Segoe UI"/>
               </a:rPr>
-              <a:t>Deliver a responsive web UI displaying endpoint profiles, compliance status, event logs, and AI findings.</a:t>
+              <a:t>Validate end-to-end data integrity from evidence ingestion to dashboard display across defined evaluation gates.</a:t>
             </a:r>
           </a:p>
         </p:txBody>
@@ -10435,12 +10435,12 @@
                 </a:solidFill>
                 <a:latin typeface="Segoe UI"/>
               </a:rPr>
-              <a:t>(Windows Server 2016-2025 / Windows 10-11): </a:t>
+              <a:t>(Windows endpoints; field validation on an authorized Windows Server host): </a:t>
             </a:r>
             <a:r>
               <a:rPr sz="1100" b="0" i="0">
                 <a:solidFill>
-                  <a:srgbClr val="0F172A"/>
+                  <a:srgbClr val="000000"/>
                 </a:solidFill>
                 <a:latin typeface="Segoe UI"/>
               </a:rPr>
@@ -10539,11 +10539,11 @@
             <a:r>
               <a:rPr sz="1100" b="0" i="0">
                 <a:solidFill>
-                  <a:srgbClr val="0F172A"/>
+                  <a:srgbClr val="000000"/>
                 </a:solidFill>
                 <a:latin typeface="Segoe UI"/>
               </a:rPr>
-              <a:t>Zero target dependencies. Self-contained runtime executing `Run-EIMS-Audit.bat` to output JSON.</a:t>
+              <a:t>Bundled runtime executing `Run-EIMS-Audit.bat`; read-only queries with outputs written to configured USB directories.</a:t>
             </a:r>
           </a:p>
         </p:txBody>
@@ -10638,7 +10638,7 @@
             <a:r>
               <a:rPr sz="1100" b="0" i="0">
                 <a:solidFill>
-                  <a:srgbClr val="0F172A"/>
+                  <a:srgbClr val="000000"/>
                 </a:solidFill>
                 <a:latin typeface="Segoe UI"/>
               </a:rPr>
@@ -10737,7 +10737,7 @@
             <a:r>
               <a:rPr sz="1100" b="0" i="0">
                 <a:solidFill>
-                  <a:srgbClr val="0F172A"/>
+                  <a:srgbClr val="000000"/>
                 </a:solidFill>
                 <a:latin typeface="Segoe UI"/>
               </a:rPr>
@@ -10836,7 +10836,7 @@
             <a:r>
               <a:rPr sz="1100" b="0" i="0">
                 <a:solidFill>
-                  <a:srgbClr val="0F172A"/>
+                  <a:srgbClr val="000000"/>
                 </a:solidFill>
                 <a:latin typeface="Segoe UI"/>
               </a:rPr>
@@ -10930,16 +10930,16 @@
                 </a:solidFill>
                 <a:latin typeface="Segoe UI"/>
               </a:rPr>
-              <a:t>(sentence-transformers (all-MiniLM-L6-v2)): </a:t>
+              <a:t>(FastEmbed (BAAI/bge-small-en-v1.5) / SentenceTransformer fallback): </a:t>
             </a:r>
             <a:r>
               <a:rPr sz="1100" b="0" i="0">
                 <a:solidFill>
-                  <a:srgbClr val="0F172A"/>
+                  <a:srgbClr val="000000"/>
                 </a:solidFill>
                 <a:latin typeface="Segoe UI"/>
               </a:rPr>
-              <a:t>Bounded retrieval-augmented generation (RAG) generating contextual diagnostic summaries.</a:t>
+              <a:t>Bounded assistive analysis generating contextual diagnostic summaries with traceable metadata.</a:t>
             </a:r>
           </a:p>
         </p:txBody>
@@ -11034,7 +11034,7 @@
             <a:r>
               <a:rPr sz="1100" b="0" i="0">
                 <a:solidFill>
-                  <a:srgbClr val="0F172A"/>
+                  <a:srgbClr val="000000"/>
                 </a:solidFill>
                 <a:latin typeface="Segoe UI"/>
               </a:rPr>
@@ -11288,7 +11288,7 @@
               </a:spcAft>
               <a:defRPr sz="1100">
                 <a:solidFill>
-                  <a:srgbClr val="0F172A"/>
+                  <a:srgbClr val="000000"/>
                 </a:solidFill>
                 <a:latin typeface="Segoe UI"/>
               </a:defRPr>
@@ -11304,7 +11304,7 @@
               </a:spcAft>
               <a:defRPr sz="1100">
                 <a:solidFill>
-                  <a:srgbClr val="0F172A"/>
+                  <a:srgbClr val="000000"/>
                 </a:solidFill>
                 <a:latin typeface="Segoe UI"/>
               </a:defRPr>
@@ -11320,7 +11320,7 @@
               </a:spcAft>
               <a:defRPr sz="1100">
                 <a:solidFill>
-                  <a:srgbClr val="0F172A"/>
+                  <a:srgbClr val="000000"/>
                 </a:solidFill>
                 <a:latin typeface="Segoe UI"/>
               </a:defRPr>
@@ -11336,7 +11336,7 @@
               </a:spcAft>
               <a:defRPr sz="1100">
                 <a:solidFill>
-                  <a:srgbClr val="0F172A"/>
+                  <a:srgbClr val="000000"/>
                 </a:solidFill>
                 <a:latin typeface="Segoe UI"/>
               </a:defRPr>
@@ -11598,7 +11598,7 @@
               </a:defRPr>
             </a:pPr>
             <a:r>
-              <a:t>•  Zero Target Footprint:</a:t>
+              <a:t>•  Bundled Runtime:</a:t>
             </a:r>
             <a:br/>
           </a:p>
@@ -11609,13 +11609,13 @@
               </a:spcAft>
               <a:defRPr sz="1050">
                 <a:solidFill>
-                  <a:srgbClr val="0F172A"/>
-                </a:solidFill>
-                <a:latin typeface="Segoe UI"/>
-              </a:defRPr>
-            </a:pPr>
-            <a:r>
-              <a:t>Requires no installed Python, Docker, or agent services on monitored servers.</a:t>
+                  <a:srgbClr val="000000"/>
+                </a:solidFill>
+                <a:latin typeface="Segoe UI"/>
+              </a:defRPr>
+            </a:pPr>
+            <a:r>
+              <a:t>Runs from USB drive with embedded CPython 3.14.3 runtime; no persistent agent installation required.</a:t>
             </a:r>
           </a:p>
           <a:p>
@@ -11631,7 +11631,7 @@
               </a:defRPr>
             </a:pPr>
             <a:r>
-              <a:t>•  Read-Only Assurance:</a:t>
+              <a:t>•  Read-Only Queries:</a:t>
             </a:r>
             <a:br/>
           </a:p>
@@ -11642,13 +11642,13 @@
               </a:spcAft>
               <a:defRPr sz="1050">
                 <a:solidFill>
-                  <a:srgbClr val="0F172A"/>
-                </a:solidFill>
-                <a:latin typeface="Segoe UI"/>
-              </a:defRPr>
-            </a:pPr>
-            <a:r>
-              <a:t>Interrogates WMI/CIM and event logs with non-destructive, read-only queries.</a:t>
+                  <a:srgbClr val="000000"/>
+                </a:solidFill>
+                <a:latin typeface="Segoe UI"/>
+              </a:defRPr>
+            </a:pPr>
+            <a:r>
+              <a:t>Interrogates WMI/CIM and event logs with non-destructive, read-only queries; writes reports/logs to configured USB directories.</a:t>
             </a:r>
           </a:p>
           <a:p>
@@ -11675,13 +11675,13 @@
               </a:spcAft>
               <a:defRPr sz="1050">
                 <a:solidFill>
-                  <a:srgbClr val="0F172A"/>
-                </a:solidFill>
-                <a:latin typeface="Segoe UI"/>
-              </a:defRPr>
-            </a:pPr>
-            <a:r>
-              <a:t>Captures System and Application logs spanning the preceding 24 hours (up to 500 events).</a:t>
+                  <a:srgbClr val="000000"/>
+                </a:solidFill>
+                <a:latin typeface="Segoe UI"/>
+              </a:defRPr>
+            </a:pPr>
+            <a:r>
+              <a:t>Captures System and Application logs spanning the preceding 24 hours (default maximum 500 events across combined query).</a:t>
             </a:r>
           </a:p>
           <a:p>
@@ -11697,7 +11697,7 @@
               </a:defRPr>
             </a:pPr>
             <a:r>
-              <a:t>•  Defensible JSON Artifact:</a:t>
+              <a:t>•  Structured JSON Artifact:</a:t>
             </a:r>
             <a:br/>
           </a:p>
@@ -11708,13 +11708,13 @@
               </a:spcAft>
               <a:defRPr sz="1050">
                 <a:solidFill>
-                  <a:srgbClr val="0F172A"/>
-                </a:solidFill>
-                <a:latin typeface="Segoe UI"/>
-              </a:defRPr>
-            </a:pPr>
-            <a:r>
-              <a:t>Generates human-readable, schema-validated JSON on the USB media prior to ingestion.</a:t>
+                  <a:srgbClr val="000000"/>
+                </a:solidFill>
+                <a:latin typeface="Segoe UI"/>
+              </a:defRPr>
+            </a:pPr>
+            <a:r>
+              <a:t>Generates structured, schema-validated JSON on the USB media prior to ingestion.</a:t>
             </a:r>
           </a:p>
         </p:txBody>
@@ -11937,7 +11937,7 @@
             <a:pPr>
               <a:defRPr sz="1100">
                 <a:solidFill>
-                  <a:srgbClr val="0F172A"/>
+                  <a:srgbClr val="000000"/>
                 </a:solidFill>
                 <a:latin typeface="Segoe UI"/>
               </a:defRPr>
@@ -12054,7 +12054,7 @@
             <a:pPr>
               <a:defRPr sz="1100">
                 <a:solidFill>
-                  <a:srgbClr val="0F172A"/>
+                  <a:srgbClr val="000000"/>
                 </a:solidFill>
                 <a:latin typeface="Segoe UI"/>
               </a:defRPr>
@@ -12171,7 +12171,7 @@
             <a:pPr>
               <a:defRPr sz="1100">
                 <a:solidFill>
-                  <a:srgbClr val="0F172A"/>
+                  <a:srgbClr val="000000"/>
                 </a:solidFill>
                 <a:latin typeface="Segoe UI"/>
               </a:defRPr>
@@ -12288,7 +12288,7 @@
             <a:pPr>
               <a:defRPr sz="1100">
                 <a:solidFill>
-                  <a:srgbClr val="0F172A"/>
+                  <a:srgbClr val="000000"/>
                 </a:solidFill>
                 <a:latin typeface="Segoe UI"/>
               </a:defRPr>
@@ -12421,13 +12421,13 @@
             <a:pPr>
               <a:defRPr sz="1100">
                 <a:solidFill>
-                  <a:srgbClr val="0F172A"/>
-                </a:solidFill>
-                <a:latin typeface="Segoe UI"/>
-              </a:defRPr>
-            </a:pPr>
-            <a:r>
-              <a:t>Because `record_id` is monotonically assigned per channel by Windows and `occurrence_time` is locked to kernel event creation, this hash is deterministic across multiple collections of the same physical event.</a:t>
+                  <a:srgbClr val="000000"/>
+                </a:solidFill>
+                <a:latin typeface="Segoe UI"/>
+              </a:defRPr>
+            </a:pPr>
+            <a:r>
+              <a:t>Here, `occurrence_time` represents the event's recorded timestamp (`TimeCreated`). Because `record_id` is monotonically assigned per channel by Windows, this hash provides deterministic deduplication across sequential collections of the same event.</a:t>
             </a:r>
           </a:p>
         </p:txBody>
@@ -12554,7 +12554,7 @@
             <a:pPr>
               <a:defRPr sz="1050">
                 <a:solidFill>
-                  <a:srgbClr val="0F172A"/>
+                  <a:srgbClr val="000000"/>
                 </a:solidFill>
                 <a:latin typeface="Segoe UI"/>
               </a:defRPr>
@@ -12635,7 +12635,7 @@
               </a:defRPr>
             </a:pPr>
             <a:r>
-              <a:t>Bounded AI-assisted Investigation &amp; Knowledge Provenance</a:t>
+              <a:t>Bounded AI-assisted Investigation &amp; Traceable Metadata</a:t>
             </a:r>
           </a:p>
         </p:txBody>
@@ -12761,7 +12761,7 @@
               </a:defRPr>
             </a:pPr>
             <a:r>
-              <a:t>Severity Prioritization &amp; Bounded Cap</a:t>
+              <a:t>Severity Prioritization &amp; Bounded Workload</a:t>
             </a:r>
           </a:p>
         </p:txBody>
@@ -12832,14 +12832,14 @@
               </a:defRPr>
             </a:pPr>
             <a:r>
-              <a:t>Workload Bounding (Analyzer Cap &lt;= 10):</a:t>
+              <a:t>Workload Bounding (Evaluated Path &lt;= 10):</a:t>
             </a:r>
           </a:p>
           <a:p>
             <a:pPr>
               <a:defRPr sz="1100">
                 <a:solidFill>
-                  <a:srgbClr val="0F172A"/>
+                  <a:srgbClr val="000000"/>
                 </a:solidFill>
                 <a:latin typeface="Segoe UI"/>
               </a:defRPr>
@@ -12849,7 +12849,7 @@
             </a:r>
             <a:br/>
             <a:r>
-              <a:t>• The analyzer evaluates at most 10 prioritized events per batch import.</a:t>
+              <a:t>• The evaluated import workflow limits analysis to at most 10 selected new events.</a:t>
             </a:r>
             <a:br/>
             <a:r>
@@ -12934,7 +12934,7 @@
               </a:defRPr>
             </a:pPr>
             <a:r>
-              <a:t>RAG Pipeline &amp; Provenance Records</a:t>
+              <a:t>Semantic Embeddings &amp; Conditional Analysis</a:t>
             </a:r>
           </a:p>
         </p:txBody>
@@ -12983,13 +12983,13 @@
               </a:spcAft>
               <a:defRPr sz="1100">
                 <a:solidFill>
-                  <a:srgbClr val="0F172A"/>
-                </a:solidFill>
-                <a:latin typeface="Segoe UI"/>
-              </a:defRPr>
-            </a:pPr>
-            <a:r>
-              <a:t>• Model: `all-MiniLM-L6-v2` (384-dimensional dense vectors).</a:t>
+                  <a:srgbClr val="000000"/>
+                </a:solidFill>
+                <a:latin typeface="Segoe UI"/>
+              </a:defRPr>
+            </a:pPr>
+            <a:r>
+              <a:t>• Model: FastEmbed `BAAI/bge-small-en-v1.5` primary (384-d dense vectors) with SentenceTransformer `all-MiniLM-L6-v2` fallback.</a:t>
             </a:r>
             <a:br/>
             <a:r>
@@ -12997,7 +12997,7 @@
             </a:r>
             <a:br/>
             <a:r>
-              <a:t>• Retrieval: Matches event logs to verified administrative playbooks.</a:t>
+              <a:t>• Flow: Checks curated answers first, then retrieval, optional Gemini generation, and fallback.</a:t>
             </a:r>
           </a:p>
           <a:p>
@@ -13020,7 +13020,7 @@
             <a:pPr>
               <a:defRPr sz="1100">
                 <a:solidFill>
-                  <a:srgbClr val="0F172A"/>
+                  <a:srgbClr val="000000"/>
                 </a:solidFill>
                 <a:latin typeface="Segoe UI"/>
               </a:defRPr>
@@ -13030,7 +13030,7 @@
             </a:r>
             <a:br/>
             <a:r>
-              <a:t>• Referential integrity: Links directly to asset entity.</a:t>
+              <a:t>• Traceable metadata: Links advice to source event and asset records.</a:t>
             </a:r>
             <a:br/>
             <a:r>

</xml_diff>

<commit_message>
docs(report): apply final precision corrections
</commit_message>
<xml_diff>
--- a/docs/presentation/EIMS_COOP_PRESENTATION_2026.pptx
+++ b/docs/presentation/EIMS_COOP_PRESENTATION_2026.pptx
@@ -1076,7 +1076,7 @@
           <a:lstStyle/>
           <a:p>
             <a:r>
-              <a:t>In enterprise IT, infrastructure evidence is scattered. Air-gapped systems cannot run continuous agents, dynamic hostnames make servers hard to identify reliably, and log volumes overwhelm staff. EIMS was designed specifically to solve these five core operational friction points.</a:t>
+              <a:t>In enterprise IT, infrastructure evidence is scattered. Air-gapped systems cannot run continuous agents, dynamic hostnames make servers hard to identify reliably, and log volumes overwhelm staff. EIMS was designed specifically to solve these five main problems.</a:t>
             </a:r>
           </a:p>
         </p:txBody>
@@ -1216,7 +1216,7 @@
           <a:lstStyle/>
           <a:p>
             <a:r>
-              <a:t>EIMS is built on modern, battle-tested open-source technologies. The collection runtime uses an embedded CPython 3.14.3 distribution on USB. The backend uses FastAPI and PostgreSQL with pgvector, decoupled through Redis and MinIO, and served via a Next.js App Router interface. The embedding service initializes FastEmbed with BAAI/bge-small-en-v1.5, with SentenceTransformer all-MiniLM-L6-v2 as fallback.</a:t>
+              <a:t>EIMS is built on the main technologies used in EIMS. The collection runtime uses an embedded CPython 3.14.3 distribution on USB. The backend uses FastAPI and PostgreSQL with pgvector, decoupled through Redis and MinIO, and served via a Next.js App Router interface. The embedding service initializes FastEmbed with BAAI/bge-small-en-v1.5, with SentenceTransformer all-MiniLM-L6-v2 as fallback.</a:t>
             </a:r>
           </a:p>
         </p:txBody>
@@ -8634,7 +8634,7 @@
               </a:defRPr>
             </a:pPr>
             <a:r>
-              <a:t>•  Host Organization: </a:t>
+              <a:t>•  Context: </a:t>
             </a:r>
             <a:r>
               <a:rPr sz="1200" b="0" i="0">
@@ -8643,32 +8643,7 @@
                 </a:solidFill>
                 <a:latin typeface="Segoe UI"/>
               </a:rPr>
-              <a:t>KANEMATSU ELECTRONICS (THAILAND)</a:t>
-            </a:r>
-          </a:p>
-          <a:p>
-            <a:pPr>
-              <a:spcAft>
-                <a:spcPts val="600"/>
-              </a:spcAft>
-              <a:defRPr sz="1200" b="1">
-                <a:solidFill>
-                  <a:srgbClr val="1E3A8A"/>
-                </a:solidFill>
-                <a:latin typeface="Segoe UI"/>
-              </a:defRPr>
-            </a:pPr>
-            <a:r>
-              <a:t>•  Industry Domain: </a:t>
-            </a:r>
-            <a:r>
-              <a:rPr sz="1200" b="0" i="0">
-                <a:solidFill>
-                  <a:srgbClr val="000000"/>
-                </a:solidFill>
-                <a:latin typeface="Segoe UI"/>
-              </a:rPr>
-              <a:t>Enterprise Systems Integration, Compute Infrastructure, and Cloud Managed Services</a:t>
+              <a:t>Cooperative education placement at KANEMATSU ELECTRONICS (THAILAND)</a:t>
             </a:r>
           </a:p>
           <a:p>
@@ -10642,7 +10617,7 @@
                 </a:solidFill>
                 <a:latin typeface="Segoe UI"/>
               </a:rPr>
-              <a:t>Asynchronous Python 3.10+ gateway delivering OpenAPI 3.1 endpoints and strict schema validation.</a:t>
+              <a:t>FastAPI + Pydantic + Starlette backend providing REST APIs and schema validation.</a:t>
             </a:r>
           </a:p>
         </p:txBody>
@@ -10840,7 +10815,7 @@
                 </a:solidFill>
                 <a:latin typeface="Segoe UI"/>
               </a:rPr>
-              <a:t>In-memory caching and message queuing paired with S3-compatible immutable blob persistence.</a:t>
+              <a:t>In-memory caching and message queuing paired with S3-compatible object storage.</a:t>
             </a:r>
           </a:p>
         </p:txBody>
@@ -11038,7 +11013,7 @@
                 </a:solidFill>
                 <a:latin typeface="Segoe UI"/>
               </a:rPr>
-              <a:t>Server/Client hybrid rendering dashboard presenting real-time asset telemetry and AI findings.</a:t>
+              <a:t>Server/Client hybrid rendering dashboard presenting asset details, compliance status, event evidence, and AI findings.</a:t>
             </a:r>
           </a:p>
         </p:txBody>
@@ -11326,7 +11301,7 @@
               </a:defRPr>
             </a:pPr>
             <a:r>
-              <a:t>•  Bounded Ingestion Pipeline: Strict schema checks and sequential deduplication ensure database integrity.</a:t>
+              <a:t>•  Bounded Ingestion Pipeline: Strict schema checks and sequential deduplication help maintain consistent stored data.</a:t>
             </a:r>
           </a:p>
           <a:p>

</xml_diff>